<commit_message>
Poster: add P-score heatmap figure to the results panel
Adds a poster-sized redraw of the four-panel P-score figure (same data,
clustering and fixed 0-1.4 colour scale as pscore_combined_four_panel.py)
and puts it above a compact accuracy chart. The three stat tiles are
dropped; the shared-variance figure moves into the contribution text.

Co-Authored-By: Claude Sonnet 5.5 <noreply@anthropic.com>
Claude-Session: https://claude.ai/code/session_01KMGKYeTRouBTWDfcYpkCFM
</commit_message>
<xml_diff>
--- a/docs/UCS2717_Poster.pptx
+++ b/docs/UCS2717_Poster.pptx
@@ -277,13 +277,13 @@
           <a:lstStyle/>
           <a:p>
             <a:r>
-              <a:rPr sz="2000" b="1">
+              <a:rPr sz="1800" b="1">
                 <a:solidFill>
                   <a:srgbClr val="15354B"/>
                 </a:solidFill>
                 <a:latin typeface="Arial"/>
               </a:rPr>
-              <a:t>Balanced accuracy, six stages</a:t>
+              <a:t>Balanced accuracy, six stages (test set used once)</a:t>
             </a:r>
           </a:p>
         </c:rich>
@@ -294,7 +294,7 @@
     <c:autoTitleDeleted val="0"/>
     <c:plotArea>
       <c:barChart>
-        <c:barDir val="bar"/>
+        <c:barDir val="col"/>
         <c:grouping val="clustered"/>
         <c:ser>
           <c:idx val="0"/>
@@ -305,7 +305,7 @@
               <c:strCache>
                 <c:ptCount val="1"/>
                 <c:pt idx="0">
-                  <c:v>Cross-validation (81 subjects)</c:v>
+                  <c:v>Cross-validation</c:v>
                 </c:pt>
               </c:strCache>
             </c:strRef>
@@ -321,22 +321,22 @@
               <c:strCache>
                 <c:ptCount val="7"/>
                 <c:pt idx="0">
-                  <c:v>Majority class (chance)</c:v>
+                  <c:v>Majority (chance)</c:v>
                 </c:pt>
                 <c:pt idx="1">
-                  <c:v>No reduction (738)</c:v>
+                  <c:v>No reduction</c:v>
                 </c:pt>
                 <c:pt idx="2">
-                  <c:v>QUBO + QAOA (8)</c:v>
+                  <c:v>QUBO + QAOA</c:v>
                 </c:pt>
                 <c:pt idx="3">
-                  <c:v>L1 logistic (10)</c:v>
+                  <c:v>L1 logistic</c:v>
                 </c:pt>
                 <c:pt idx="4">
-                  <c:v>PCA (10)</c:v>
+                  <c:v>PCA</c:v>
                 </c:pt>
                 <c:pt idx="5">
-                  <c:v>MLP on DC_z</c:v>
+                  <c:v>MLP (DC_z)</c:v>
                 </c:pt>
                 <c:pt idx="6">
                   <c:v>Transformer</c:v>
@@ -400,22 +400,22 @@
               <c:strCache>
                 <c:ptCount val="7"/>
                 <c:pt idx="0">
-                  <c:v>Majority class (chance)</c:v>
+                  <c:v>Majority (chance)</c:v>
                 </c:pt>
                 <c:pt idx="1">
-                  <c:v>No reduction (738)</c:v>
+                  <c:v>No reduction</c:v>
                 </c:pt>
                 <c:pt idx="2">
-                  <c:v>QUBO + QAOA (8)</c:v>
+                  <c:v>QUBO + QAOA</c:v>
                 </c:pt>
                 <c:pt idx="3">
-                  <c:v>L1 logistic (10)</c:v>
+                  <c:v>L1 logistic</c:v>
                 </c:pt>
                 <c:pt idx="4">
-                  <c:v>PCA (10)</c:v>
+                  <c:v>PCA</c:v>
                 </c:pt>
                 <c:pt idx="5">
-                  <c:v>MLP on DC_z</c:v>
+                  <c:v>MLP (DC_z)</c:v>
                 </c:pt>
                 <c:pt idx="6">
                   <c:v>Transformer</c:v>
@@ -452,7 +452,7 @@
             <a:lstStyle/>
             <a:p>
               <a:pPr>
-                <a:defRPr sz="1600">
+                <a:defRPr sz="1400">
                   <a:solidFill>
                     <a:srgbClr val="15354B"/>
                   </a:solidFill>
@@ -470,7 +470,7 @@
           <c:showBubbleSize val="0"/>
           <c:showLeaderLines val="1"/>
         </c:dLbls>
-        <c:gapWidth val="55"/>
+        <c:gapWidth val="40"/>
         <c:overlap val="-5"/>
         <c:axId val="-2068027336"/>
         <c:axId val="-2113994440"/>
@@ -481,7 +481,7 @@
           <c:orientation val="minMax"/>
         </c:scaling>
         <c:delete val="0"/>
-        <c:axPos val="l"/>
+        <c:axPos val="b"/>
         <c:majorTickMark val="out"/>
         <c:minorTickMark val="none"/>
         <c:tickLblPos val="nextTo"/>
@@ -497,7 +497,7 @@
           <a:lstStyle/>
           <a:p>
             <a:pPr>
-              <a:defRPr sz="1600">
+              <a:defRPr sz="1400">
                 <a:solidFill>
                   <a:srgbClr val="15354B"/>
                 </a:solidFill>
@@ -520,7 +520,7 @@
           <c:min val="0.0"/>
         </c:scaling>
         <c:delete val="0"/>
-        <c:axPos val="b"/>
+        <c:axPos val="l"/>
         <c:majorGridlines>
           <c:spPr>
             <a:ln>
@@ -544,7 +544,7 @@
           <a:lstStyle/>
           <a:p>
             <a:pPr>
-              <a:defRPr sz="1600">
+              <a:defRPr sz="1400">
                 <a:solidFill>
                   <a:srgbClr val="506575"/>
                 </a:solidFill>
@@ -566,7 +566,7 @@
         <a:lstStyle/>
         <a:p>
           <a:pPr>
-            <a:defRPr sz="1600">
+            <a:defRPr sz="1400">
               <a:solidFill>
                 <a:srgbClr val="506575"/>
               </a:solidFill>
@@ -846,6 +846,21 @@
           <a:p>
             <a:r>
               <a:t>- MLP on DC_z held-out balanced accuracy 0.200; its CV score (0.307) did not carry over.</a:t>
+            </a:r>
+          </a:p>
+          <a:p>
+            <a:r>
+              <a:t>- Chart protocol: transformer = 5-fold CV; others = 5 seeds x 5 folds. Feature counts: no reduction 738, QUBO+QAOA 8, L1 10, PCA 10 components.</a:t>
+            </a:r>
+          </a:p>
+          <a:p>
+            <a:r>
+              <a:t>- P-score figure: poster-sized redraw (scripts/audit/pscore_poster_panel.py) of the four-panel variant, fixed 0-1.4 scale, so panels are comparable; max P-score 0.928 (mReHo) vs threshold 1.301. 0 of 5,904 ROI-stage tests reach q &lt; 0.05.</a:t>
+            </a:r>
+          </a:p>
+          <a:p>
+            <a:r>
+              <a:t>- Smallest adjusted q in any test: 0.139 (one-vs-rest ROI x stage family).</a:t>
             </a:r>
           </a:p>
           <a:p>
@@ -5067,7 +5082,7 @@
                 </a:solidFill>
                 <a:latin typeface="Arial"/>
               </a:rPr>
-              <a:t>A verified DICOM-to-features pipeline, a proven FC_Strength redundancy (= DC/245), and a leak-free benchmark of 26 feature-reduction methods including quantum QUBO.</a:t>
+              <a:t>A verified DICOM-to-features pipeline, a proven FC_Strength redundancy (= DC/245), 5.7–11.3% shared variance between biomarkers, and a leak-free benchmark of 26 feature-reduction methods including quantum QUBO.</a:t>
             </a:r>
           </a:p>
           <a:p>
@@ -7331,235 +7346,40 @@
           </a:graphicData>
         </a:graphic>
       </p:graphicFrame>
-      <p:graphicFrame>
-        <p:nvGraphicFramePr>
-          <p:cNvPr id="70" name="Accuracy chart"/>
-          <p:cNvGraphicFramePr>
-            <a:graphicFrameLocks noGrp="1"/>
-          </p:cNvGraphicFramePr>
+      <p:pic>
+        <p:nvPicPr>
+          <p:cNvPr id="70" name="P-score heatmaps" descr="pscore_poster_panel.png"/>
+          <p:cNvPicPr>
+            <a:picLocks noChangeAspect="1"/>
+          </p:cNvPicPr>
           <p:nvPr/>
-        </p:nvGraphicFramePr>
-        <p:xfrm>
-          <a:off x="20162520" y="5148072"/>
-          <a:ext cx="9326880" cy="5074920"/>
-        </p:xfrm>
-        <a:graphic>
-          <a:graphicData uri="http://schemas.openxmlformats.org/drawingml/2006/chart">
-            <c:chart xmlns:c="http://schemas.openxmlformats.org/drawingml/2006/chart" r:id="rId4"/>
-          </a:graphicData>
-        </a:graphic>
-      </p:graphicFrame>
+        </p:nvPicPr>
+        <p:blipFill>
+          <a:blip r:embed="rId4"/>
+          <a:stretch>
+            <a:fillRect/>
+          </a:stretch>
+        </p:blipFill>
+        <p:spPr>
+          <a:xfrm>
+            <a:off x="20208239" y="5166360"/>
+            <a:ext cx="9235440" cy="4754880"/>
+          </a:xfrm>
+          <a:prstGeom prst="rect">
+            <a:avLst/>
+          </a:prstGeom>
+        </p:spPr>
+      </p:pic>
       <p:sp>
         <p:nvSpPr>
-          <p:cNvPr id="71" name="Stat tile"/>
-          <p:cNvSpPr/>
-          <p:nvPr/>
-        </p:nvSpPr>
-        <p:spPr>
-          <a:xfrm>
-            <a:off x="20253960" y="10405872"/>
-            <a:ext cx="2926079" cy="1920240"/>
-          </a:xfrm>
-          <a:prstGeom prst="roundRect">
-            <a:avLst>
-              <a:gd name="adj" fmla="val 8000"/>
-            </a:avLst>
-          </a:prstGeom>
-          <a:solidFill>
-            <a:srgbClr val="E3F1F3"/>
-          </a:solidFill>
-          <a:ln>
-            <a:noFill/>
-          </a:ln>
-          <a:effectLst/>
-        </p:spPr>
-        <p:style>
-          <a:lnRef idx="1">
-            <a:schemeClr val="accent1"/>
-          </a:lnRef>
-          <a:fillRef idx="3">
-            <a:schemeClr val="accent1"/>
-          </a:fillRef>
-          <a:effectRef idx="2">
-            <a:schemeClr val="accent1"/>
-          </a:effectRef>
-          <a:fontRef idx="minor">
-            <a:schemeClr val="lt1"/>
-          </a:fontRef>
-        </p:style>
-        <p:txBody>
-          <a:bodyPr rtlCol="0" anchor="ctr" wrap="square" lIns="109728" rIns="109728"/>
-          <a:lstStyle/>
-          <a:p>
-            <a:pPr algn="l"/>
-            <a:r>
-              <a:rPr sz="3400" b="1">
-                <a:solidFill>
-                  <a:srgbClr val="087F8C"/>
-                </a:solidFill>
-                <a:latin typeface="Arial"/>
-              </a:rPr>
-              <a:t>0.139</a:t>
-            </a:r>
-          </a:p>
-          <a:p>
-            <a:pPr algn="l"/>
-            <a:r>
-              <a:rPr sz="1600">
-                <a:solidFill>
-                  <a:srgbClr val="15354B"/>
-                </a:solidFill>
-                <a:latin typeface="Arial"/>
-              </a:rPr>
-              <a:t>smallest adjusted q in any test (needs &lt; 0.05)</a:t>
-            </a:r>
-          </a:p>
-        </p:txBody>
-      </p:sp>
-      <p:sp>
-        <p:nvSpPr>
-          <p:cNvPr id="72" name="Stat tile"/>
-          <p:cNvSpPr/>
-          <p:nvPr/>
-        </p:nvSpPr>
-        <p:spPr>
-          <a:xfrm>
-            <a:off x="23362919" y="10405872"/>
-            <a:ext cx="2926079" cy="1920240"/>
-          </a:xfrm>
-          <a:prstGeom prst="roundRect">
-            <a:avLst>
-              <a:gd name="adj" fmla="val 8000"/>
-            </a:avLst>
-          </a:prstGeom>
-          <a:solidFill>
-            <a:srgbClr val="E3F1F3"/>
-          </a:solidFill>
-          <a:ln>
-            <a:noFill/>
-          </a:ln>
-          <a:effectLst/>
-        </p:spPr>
-        <p:style>
-          <a:lnRef idx="1">
-            <a:schemeClr val="accent1"/>
-          </a:lnRef>
-          <a:fillRef idx="3">
-            <a:schemeClr val="accent1"/>
-          </a:fillRef>
-          <a:effectRef idx="2">
-            <a:schemeClr val="accent1"/>
-          </a:effectRef>
-          <a:fontRef idx="minor">
-            <a:schemeClr val="lt1"/>
-          </a:fontRef>
-        </p:style>
-        <p:txBody>
-          <a:bodyPr rtlCol="0" anchor="ctr" wrap="square" lIns="109728" rIns="109728"/>
-          <a:lstStyle/>
-          <a:p>
-            <a:pPr algn="l"/>
-            <a:r>
-              <a:rPr sz="3400" b="1">
-                <a:solidFill>
-                  <a:srgbClr val="087F8C"/>
-                </a:solidFill>
-                <a:latin typeface="Arial"/>
-              </a:rPr>
-              <a:t>5.7–11.3%</a:t>
-            </a:r>
-          </a:p>
-          <a:p>
-            <a:pPr algn="l"/>
-            <a:r>
-              <a:rPr sz="1600">
-                <a:solidFill>
-                  <a:srgbClr val="15354B"/>
-                </a:solidFill>
-                <a:latin typeface="Arial"/>
-              </a:rPr>
-              <a:t>variance shared between the four biomarkers</a:t>
-            </a:r>
-          </a:p>
-        </p:txBody>
-      </p:sp>
-      <p:sp>
-        <p:nvSpPr>
-          <p:cNvPr id="73" name="Stat tile"/>
-          <p:cNvSpPr/>
-          <p:nvPr/>
-        </p:nvSpPr>
-        <p:spPr>
-          <a:xfrm>
-            <a:off x="26471880" y="10405872"/>
-            <a:ext cx="2926079" cy="1920240"/>
-          </a:xfrm>
-          <a:prstGeom prst="roundRect">
-            <a:avLst>
-              <a:gd name="adj" fmla="val 8000"/>
-            </a:avLst>
-          </a:prstGeom>
-          <a:solidFill>
-            <a:srgbClr val="E3F1F3"/>
-          </a:solidFill>
-          <a:ln>
-            <a:noFill/>
-          </a:ln>
-          <a:effectLst/>
-        </p:spPr>
-        <p:style>
-          <a:lnRef idx="1">
-            <a:schemeClr val="accent1"/>
-          </a:lnRef>
-          <a:fillRef idx="3">
-            <a:schemeClr val="accent1"/>
-          </a:fillRef>
-          <a:effectRef idx="2">
-            <a:schemeClr val="accent1"/>
-          </a:effectRef>
-          <a:fontRef idx="minor">
-            <a:schemeClr val="lt1"/>
-          </a:fontRef>
-        </p:style>
-        <p:txBody>
-          <a:bodyPr rtlCol="0" anchor="ctr" wrap="square" lIns="109728" rIns="109728"/>
-          <a:lstStyle/>
-          <a:p>
-            <a:pPr algn="l"/>
-            <a:r>
-              <a:rPr sz="3400" b="1">
-                <a:solidFill>
-                  <a:srgbClr val="087F8C"/>
-                </a:solidFill>
-                <a:latin typeface="Arial"/>
-              </a:rPr>
-              <a:t>0.17–0.23</a:t>
-            </a:r>
-          </a:p>
-          <a:p>
-            <a:pPr algn="l"/>
-            <a:r>
-              <a:rPr sz="1600">
-                <a:solidFill>
-                  <a:srgbClr val="15354B"/>
-                </a:solidFill>
-                <a:latin typeface="Arial"/>
-              </a:rPr>
-              <a:t>held-out balanced accuracy; chance is 0.167</a:t>
-            </a:r>
-          </a:p>
-        </p:txBody>
-      </p:sp>
-      <p:sp>
-        <p:nvSpPr>
-          <p:cNvPr id="74" name="Chart footnote"/>
+          <p:cNvPr id="71" name="P-score caption"/>
           <p:cNvSpPr txBox="1"/>
           <p:nvPr/>
         </p:nvSpPr>
         <p:spPr>
           <a:xfrm>
-            <a:off x="20253960" y="12508992"/>
-            <a:ext cx="9144000" cy="868680"/>
+            <a:off x="20208239" y="9966960"/>
+            <a:ext cx="9235440" cy="566928"/>
           </a:xfrm>
           <a:prstGeom prst="rect">
             <a:avLst/>
@@ -7580,14 +7400,32 @@
                 </a:solidFill>
                 <a:latin typeface="Arial"/>
               </a:rPr>
-              <a:t>Transformer: 5-fold CV. Others: 5 seeds x 5 folds. Test set used once; no result is significantly above chance (p &gt; 0.2).</a:t>
+              <a:t>P-score = −log10(q) for every ROI and stage, one 0–1.4 scale. Significance needs 1.30; the largest value is 0.93, so no cell qualifies.</a:t>
             </a:r>
           </a:p>
         </p:txBody>
       </p:sp>
+      <p:graphicFrame>
+        <p:nvGraphicFramePr>
+          <p:cNvPr id="72" name="Accuracy chart"/>
+          <p:cNvGraphicFramePr>
+            <a:graphicFrameLocks noGrp="1"/>
+          </p:cNvGraphicFramePr>
+          <p:nvPr/>
+        </p:nvGraphicFramePr>
+        <p:xfrm>
+          <a:off x="20162520" y="10533888"/>
+          <a:ext cx="9326880" cy="2843783"/>
+        </p:xfrm>
+        <a:graphic>
+          <a:graphicData uri="http://schemas.openxmlformats.org/drawingml/2006/chart">
+            <c:chart xmlns:c="http://schemas.openxmlformats.org/drawingml/2006/chart" r:id="rId5"/>
+          </a:graphicData>
+        </a:graphic>
+      </p:graphicFrame>
       <p:sp>
         <p:nvSpPr>
-          <p:cNvPr id="75" name="Acknowledgement"/>
+          <p:cNvPr id="73" name="Acknowledgement"/>
           <p:cNvSpPr txBox="1"/>
           <p:nvPr/>
         </p:nvSpPr>

</xml_diff>

<commit_message>
Poster: use the blue-red P-score heatmap
Adds a blue-red mode to pscore_poster_panel.py (RdBu_r, per-panel scale:
blue = P 0, pale = panel median, red = 99th percentile) and switches the
poster to it. The caption states that colour is relative within each
panel and that no cell reaches q < 0.05. The fixed-scale yellow version
is kept alongside.

Co-Authored-By: Claude Sonnet 5.5 <noreply@anthropic.com>
Claude-Session: https://claude.ai/code/session_01KMGKYeTRouBTWDfcYpkCFM
</commit_message>
<xml_diff>
--- a/docs/UCS2717_Poster.pptx
+++ b/docs/UCS2717_Poster.pptx
@@ -855,7 +855,7 @@
           </a:p>
           <a:p>
             <a:r>
-              <a:t>- P-score figure: poster-sized redraw (scripts/audit/pscore_poster_panel.py) of the four-panel variant, fixed 0-1.4 scale, so panels are comparable; max P-score 0.928 (mReHo) vs threshold 1.301. 0 of 5,904 ROI-stage tests reach q &lt; 0.05.</a:t>
+              <a:t>- P-score figure: poster-sized redraw (scripts/audit/pscore_poster_panel.py blue) of the four-panel variant, RdBu_r with a per-panel scale (blue = P 0, pale = panel median, red = 99th percentile), so panels are NOT comparable; the yellow fixed-scale version is pscore_poster_panel.png; max P-score 0.928 (mReHo) vs threshold 1.301. 0 of 5,904 ROI-stage tests reach q &lt; 0.05.</a:t>
             </a:r>
           </a:p>
           <a:p>
@@ -7348,7 +7348,7 @@
       </p:graphicFrame>
       <p:pic>
         <p:nvPicPr>
-          <p:cNvPr id="70" name="P-score heatmaps" descr="pscore_poster_panel.png"/>
+          <p:cNvPr id="70" name="P-score heatmaps" descr="pscore_poster_panel_blue.png"/>
           <p:cNvPicPr>
             <a:picLocks noChangeAspect="1"/>
           </p:cNvPicPr>
@@ -7400,7 +7400,7 @@
                 </a:solidFill>
                 <a:latin typeface="Arial"/>
               </a:rPr>
-              <a:t>P-score = −log10(q) for every ROI and stage, one 0–1.4 scale. Significance needs 1.30; the largest value is 0.93, so no cell qualifies.</a:t>
+              <a:t>P-score = −log10(q). Colour is relative within each panel (blue = 0, red = top 1%), so panels are not comparable. Significance needs 1.30; the largest value is 0.93, so no cell qualifies.</a:t>
             </a:r>
           </a:p>
         </p:txBody>

</xml_diff>